<commit_message>
Correct Shenli framing: sub-tier supplier, size unverified
Per Merit's Jun 11 2024 recall notice (Cameron's meeting notes).

Co-Authored-By: Claude Opus 5.5 <noreply@anthropic.com>
</commit_message>
<xml_diff>
--- a/deck/Merit-Supplier-Ladder-v1.pptx
+++ b/deck/Merit-Supplier-Ladder-v1.pptx
@@ -127,14 +127,14 @@
   <p:extLst>
     <p:ext uri="{521415D9-36F7-43E2-AB2F-B90AF26B5E84}">
       <p14:sectionLst xmlns:p14="http://schemas.microsoft.com/office/powerpoint/2010/main">
-        <p14:section name="Opening" id="{5a243f0c-29e9-db81-7c90-abc5b414d8a7}">
+        <p14:section name="Opening" id="{00f9311d-ff38-a8d6-5cc5-d6413ade1660}">
           <p14:sldIdLst>
             <p14:sldId id="256"/>
             <p14:sldId id="257"/>
             <p14:sldId id="258"/>
           </p14:sldIdLst>
         </p14:section>
-        <p14:section name="The plan" id="{342f7c34-b4eb-4f55-a704-c287bc12d874}">
+        <p14:section name="The plan" id="{41c5f92c-4bb7-d7a3-8915-c85439b4e024}">
           <p14:sldIdLst>
             <p14:sldId id="259"/>
             <p14:sldId id="260"/>
@@ -142,20 +142,20 @@
             <p14:sldId id="262"/>
           </p14:sldIdLst>
         </p14:section>
-        <p14:section name="Proof" id="{b71ad91a-9004-5400-a233-8ca9fd05db41}">
+        <p14:section name="Proof" id="{f02359c6-d893-2abb-54a5-30701ca099be}">
           <p14:sldIdLst>
             <p14:sldId id="263"/>
             <p14:sldId id="264"/>
             <p14:sldId id="265"/>
           </p14:sldIdLst>
         </p14:section>
-        <p14:section name="Close" id="{0ac05fce-dfce-6101-397a-44e49f358d63}">
+        <p14:section name="Close" id="{530687b7-0b4a-2d93-9e20-c225d0cc5a5a}">
           <p14:sldIdLst>
             <p14:sldId id="266"/>
             <p14:sldId id="267"/>
           </p14:sldIdLst>
         </p14:section>
-        <p14:section name="Backup" id="{1d79e4d2-6d39-2650-4d6b-b2348c5c3ad9}">
+        <p14:section name="Backup" id="{465726ef-6462-7ebf-e445-e77aa6d8335d}">
           <p14:sldIdLst>
             <p14:sldId id="268"/>
             <p14:sldId id="269"/>
@@ -1056,7 +1056,7 @@
           <a:p>
             <a:r>
               <a:rPr lang="en-US" dirty="0"/>
-              <a:t>Hook (Elijah, 0:30). In 2024 Jiangsu Shenli, a small Chinese syringe maker inside Merit's custom kits, got an FDA warning letter (March). Merit recalled the kits (Class II, June) and Cardinal Health's kits that contained them were recalled too. This was a quality/regulatory failure, not an emissions one. The point is visibility: the same blind spot that let an uncleared part into our kits also hides labor and emissions risk. 'Today we'll show how Merit catches the next one earlier.' Sources: FDA warning letter Mar 2024; FDA recall database Jun 2024.</a:t>
+              <a:t>Hook (Elijah, 0:30). In 2024 Jiangsu Shenli, a Chinese syringe maker whose syringes reached Merit's custom kits through one of Merit's suppliers, got an FDA warning letter (March). Merit recalled the kits (Class II, June) and Cardinal Health's kits that contained them were recalled too. This was a quality/regulatory failure, not an emissions one. The point is visibility: the same blind spot that let an uncleared part into our kits also hides labor and emissions risk. 'Today we'll show how Merit catches the next one earlier.' Sources: FDA warning letter Mar 2024; FDA recall database Jun 2024.</a:t>
             </a:r>
             <a:endParaRPr lang="en-US" dirty="0"/>
           </a:p>

</xml_diff>